<commit_message>
Update PowerPoint for song #1 in FUBC - Українські
</commit_message>
<xml_diff>
--- a/fubc-ua/1-Пoнaд Влaду (Above All Powers).pptx
+++ b/fubc-ua/1-Пoнaд Влaду (Above All Powers).pptx
@@ -510,7 +510,7 @@
           <a:p>
             <a:r>
               <a:rPr lang="en-US" dirty="0"/>
-              <a:t/>
+              <a:t>T · 1/1</a:t>
             </a:r>
             <a:endParaRPr lang="en-US" dirty="0"/>
           </a:p>
@@ -598,7 +598,7 @@
           <a:p>
             <a:r>
               <a:rPr lang="en-US" dirty="0"/>
-              <a:t/>
+              <a:t>1 · 1/2</a:t>
             </a:r>
             <a:endParaRPr lang="en-US" dirty="0"/>
           </a:p>
@@ -686,7 +686,7 @@
           <a:p>
             <a:r>
               <a:rPr lang="en-US" dirty="0"/>
-              <a:t/>
+              <a:t>1 · 2/2</a:t>
             </a:r>
             <a:endParaRPr lang="en-US" dirty="0"/>
           </a:p>
@@ -774,7 +774,7 @@
           <a:p>
             <a:r>
               <a:rPr lang="en-US" dirty="0"/>
-              <a:t/>
+              <a:t>P · 1/1</a:t>
             </a:r>
             <a:endParaRPr lang="en-US" dirty="0"/>
           </a:p>
@@ -862,7 +862,7 @@
           <a:p>
             <a:r>
               <a:rPr lang="en-US" dirty="0"/>
-              <a:t/>
+              <a:t>2 · 1/2</a:t>
             </a:r>
             <a:endParaRPr lang="en-US" dirty="0"/>
           </a:p>
@@ -950,7 +950,7 @@
           <a:p>
             <a:r>
               <a:rPr lang="en-US" dirty="0"/>
-              <a:t/>
+              <a:t>2 · 2/2</a:t>
             </a:r>
             <a:endParaRPr lang="en-US" dirty="0"/>
           </a:p>
@@ -1038,7 +1038,7 @@
           <a:p>
             <a:r>
               <a:rPr lang="en-US" dirty="0"/>
-              <a:t/>
+              <a:t>P · 1/1</a:t>
             </a:r>
             <a:endParaRPr lang="en-US" dirty="0"/>
           </a:p>
@@ -1126,7 +1126,7 @@
           <a:p>
             <a:r>
               <a:rPr lang="en-US" dirty="0"/>
-              <a:t/>
+              <a:t>P · 1/1</a:t>
             </a:r>
             <a:endParaRPr lang="en-US" dirty="0"/>
           </a:p>
@@ -1765,6 +1765,45 @@
           </a:p>
         </p:txBody>
       </p:sp>
+      <p:sp>
+        <p:nvSpPr>
+          <p:cNvPr id="3" name="Text 1"/>
+          <p:cNvSpPr txBox="1"/>
+          <p:nvPr/>
+        </p:nvSpPr>
+        <p:spPr>
+          <a:xfrm>
+            <a:off x="9235440" y="6126480"/>
+            <a:ext cx="2743200" cy="548640"/>
+          </a:xfrm>
+          <a:prstGeom prst="rect">
+            <a:avLst/>
+          </a:prstGeom>
+          <a:noFill/>
+          <a:ln/>
+        </p:spPr>
+        <p:txBody>
+          <a:bodyPr wrap="square" lIns="0" tIns="0" rIns="0" bIns="0" rtlCol="0" anchor="ctr"/>
+          <a:lstStyle/>
+          <a:p>
+            <a:pPr algn="r" indent="0" marL="0">
+              <a:buNone/>
+            </a:pPr>
+            <a:r>
+              <a:rPr lang="en-US" sz="2400" dirty="0">
+                <a:solidFill>
+                  <a:srgbClr val="8A8A8A"/>
+                </a:solidFill>
+                <a:latin typeface="Arial" pitchFamily="34" charset="0"/>
+                <a:ea typeface="Arial" pitchFamily="34" charset="-122"/>
+                <a:cs typeface="Arial" pitchFamily="34" charset="-120"/>
+              </a:rPr>
+              <a:t>● ○</a:t>
+            </a:r>
+            <a:endParaRPr lang="en-US" sz="2400" dirty="0"/>
+          </a:p>
+        </p:txBody>
+      </p:sp>
     </p:spTree>
   </p:cSld>
   <p:clrMapOvr>
@@ -1887,6 +1926,45 @@
           </a:p>
         </p:txBody>
       </p:sp>
+      <p:sp>
+        <p:nvSpPr>
+          <p:cNvPr id="3" name="Text 1"/>
+          <p:cNvSpPr txBox="1"/>
+          <p:nvPr/>
+        </p:nvSpPr>
+        <p:spPr>
+          <a:xfrm>
+            <a:off x="9235440" y="6126480"/>
+            <a:ext cx="2743200" cy="548640"/>
+          </a:xfrm>
+          <a:prstGeom prst="rect">
+            <a:avLst/>
+          </a:prstGeom>
+          <a:noFill/>
+          <a:ln/>
+        </p:spPr>
+        <p:txBody>
+          <a:bodyPr wrap="square" lIns="0" tIns="0" rIns="0" bIns="0" rtlCol="0" anchor="ctr"/>
+          <a:lstStyle/>
+          <a:p>
+            <a:pPr algn="r" indent="0" marL="0">
+              <a:buNone/>
+            </a:pPr>
+            <a:r>
+              <a:rPr lang="en-US" sz="2400" dirty="0">
+                <a:solidFill>
+                  <a:srgbClr val="8A8A8A"/>
+                </a:solidFill>
+                <a:latin typeface="Arial" pitchFamily="34" charset="0"/>
+                <a:ea typeface="Arial" pitchFamily="34" charset="-122"/>
+                <a:cs typeface="Arial" pitchFamily="34" charset="-120"/>
+              </a:rPr>
+              <a:t>○ ●</a:t>
+            </a:r>
+            <a:endParaRPr lang="en-US" sz="2400" dirty="0"/>
+          </a:p>
+        </p:txBody>
+      </p:sp>
     </p:spTree>
   </p:cSld>
   <p:clrMapOvr>
@@ -2131,6 +2209,45 @@
           </a:p>
         </p:txBody>
       </p:sp>
+      <p:sp>
+        <p:nvSpPr>
+          <p:cNvPr id="3" name="Text 1"/>
+          <p:cNvSpPr txBox="1"/>
+          <p:nvPr/>
+        </p:nvSpPr>
+        <p:spPr>
+          <a:xfrm>
+            <a:off x="9235440" y="6126480"/>
+            <a:ext cx="2743200" cy="548640"/>
+          </a:xfrm>
+          <a:prstGeom prst="rect">
+            <a:avLst/>
+          </a:prstGeom>
+          <a:noFill/>
+          <a:ln/>
+        </p:spPr>
+        <p:txBody>
+          <a:bodyPr wrap="square" lIns="0" tIns="0" rIns="0" bIns="0" rtlCol="0" anchor="ctr"/>
+          <a:lstStyle/>
+          <a:p>
+            <a:pPr algn="r" indent="0" marL="0">
+              <a:buNone/>
+            </a:pPr>
+            <a:r>
+              <a:rPr lang="en-US" sz="2400" dirty="0">
+                <a:solidFill>
+                  <a:srgbClr val="8A8A8A"/>
+                </a:solidFill>
+                <a:latin typeface="Arial" pitchFamily="34" charset="0"/>
+                <a:ea typeface="Arial" pitchFamily="34" charset="-122"/>
+                <a:cs typeface="Arial" pitchFamily="34" charset="-120"/>
+              </a:rPr>
+              <a:t>● ○</a:t>
+            </a:r>
+            <a:endParaRPr lang="en-US" sz="2400" dirty="0"/>
+          </a:p>
+        </p:txBody>
+      </p:sp>
     </p:spTree>
   </p:cSld>
   <p:clrMapOvr>
@@ -2250,6 +2367,45 @@
               <a:t>А Tи для мeнe мaєш їx бeз мeж.</a:t>
             </a:r>
             <a:endParaRPr lang="en-US" sz="4700" dirty="0"/>
+          </a:p>
+        </p:txBody>
+      </p:sp>
+      <p:sp>
+        <p:nvSpPr>
+          <p:cNvPr id="3" name="Text 1"/>
+          <p:cNvSpPr txBox="1"/>
+          <p:nvPr/>
+        </p:nvSpPr>
+        <p:spPr>
+          <a:xfrm>
+            <a:off x="9235440" y="6126480"/>
+            <a:ext cx="2743200" cy="548640"/>
+          </a:xfrm>
+          <a:prstGeom prst="rect">
+            <a:avLst/>
+          </a:prstGeom>
+          <a:noFill/>
+          <a:ln/>
+        </p:spPr>
+        <p:txBody>
+          <a:bodyPr wrap="square" lIns="0" tIns="0" rIns="0" bIns="0" rtlCol="0" anchor="ctr"/>
+          <a:lstStyle/>
+          <a:p>
+            <a:pPr algn="r" indent="0" marL="0">
+              <a:buNone/>
+            </a:pPr>
+            <a:r>
+              <a:rPr lang="en-US" sz="2400" dirty="0">
+                <a:solidFill>
+                  <a:srgbClr val="8A8A8A"/>
+                </a:solidFill>
+                <a:latin typeface="Arial" pitchFamily="34" charset="0"/>
+                <a:ea typeface="Arial" pitchFamily="34" charset="-122"/>
+                <a:cs typeface="Arial" pitchFamily="34" charset="-120"/>
+              </a:rPr>
+              <a:t>○ ●</a:t>
+            </a:r>
+            <a:endParaRPr lang="en-US" sz="2400" dirty="0"/>
           </a:p>
         </p:txBody>
       </p:sp>

</xml_diff>